<commit_message>
docs(event): slide 10 năm bản nâng cấp — logo thật + 3 ảnh công trình (Q7/Bình Chánh/Gò Vấp) + ảnh teambuilding + số liệu jamahome.vn (100+ công trình cải tạo 2025)
Co-Authored-By: Claude Fable 5 <noreply@anthropic.com>
</commit_message>
<xml_diff>
--- a/docs/event/JAMA-ERP-10-nam.pptx
+++ b/docs/event/JAMA-ERP-10-nam.pptx
@@ -512,7 +512,7 @@
           <a:lstStyle/>
           <a:p>
             <a:r>
-              <a:t>Chào mừng cả nhà đến sinh nhật 10 tuổi JAMA HOME. Hôm nay ngoài kỷ niệm, chúng ta ra mắt một thành viên mới: JAMA ERP — hệ thống do chính chúng ta xây cho chính chúng ta.</a:t>
+              <a:t>Chào mừng cả nhà đến sinh nhật 10 tuổi JAMA HOME. Ba tấm ảnh dưới là công trình thật của chính chúng ta (Q7, Bình Chánh, Gò Vấp). Hôm nay ngoài kỷ niệm, ta ra mắt JAMA ERP — hệ thống do chính chúng ta xây cho chính chúng ta.</a:t>
             </a:r>
           </a:p>
         </p:txBody>
@@ -598,7 +598,7 @@
           <a:lstStyle/>
           <a:p>
             <a:r>
-              <a:t>Customer Portal: khách tự xem tiến độ nhà mình + nghiệm thu online. Uy tín hôm nay = hợp đồng ngày mai — nguồn giới thiệu là kênh rẻ nhất, chất nhất.</a:t>
+              <a:t>Customer Portal: khách tự xem tiến độ + nghiệm thu online. Uy tín hôm nay = hợp đồng ngày mai.</a:t>
             </a:r>
           </a:p>
         </p:txBody>
@@ -684,7 +684,7 @@
           <a:lstStyle/>
           <a:p>
             <a:r>
-              <a:t>Kết nối lợi ích: công ty thắng thì anh em thắng — năng suất, thu nhập, cơ hội sự nghiệp trong thời đại mở cửa. Đọc chậm câu quote cuối.</a:t>
+              <a:t>Kết nối lợi ích: công ty thắng thì anh em thắng — năng suất, thu nhập, cơ hội. Đọc chậm câu quote.</a:t>
             </a:r>
           </a:p>
         </p:txBody>
@@ -770,7 +770,7 @@
           <a:lstStyle/>
           <a:p>
             <a:r>
-              <a:t>Kêu gọi hành động cụ thể 3 việc: đăng nhập hôm nay, liên kết Telegram, mọi việc lên hệ thống. Chốt: 10 năm nền móng — thập kỷ bứt phá bắt đầu từ hôm nay. Cảm ơn cả nhà!</a:t>
+              <a:t>Ảnh teambuilding = chính chúng ta. Kêu gọi 3 việc: đăng nhập hôm nay, liên kết Telegram, mọi việc lên hệ thống. Chốt: 10 năm nền móng — thập kỷ bứt phá bắt đầu từ hôm nay!</a:t>
             </a:r>
           </a:p>
         </p:txBody>
@@ -856,7 +856,7 @@
           <a:lstStyle/>
           <a:p>
             <a:r>
-              <a:t>Nhấn mạnh: 10 năm qua là nền móng. Thời đại Việt Nam mở cửa = cơ hội khổng lồ nhưng ai nhanh hơn người đó thắng. ERP là cách chúng ta chạy nhanh hơn thị trường.</a:t>
+              <a:t>Nhấn số liệu thật: 100+ công trình cải tạo riêng 2025, dẫn đầu TP.HCM. Thời đại Việt Nam mở cửa = cơ hội khổng lồ nhưng ai nhanh hơn người đó thắng. ERP là cách chúng ta chạy nhanh hơn thị trường.</a:t>
             </a:r>
           </a:p>
         </p:txBody>
@@ -942,7 +942,7 @@
           <a:lstStyle/>
           <a:p>
             <a:r>
-              <a:t>Giải thích ngắn gọn ERP là gì bằng ngôn ngữ đời thường: toàn bộ công ty trên một hệ thống, một nguồn số thật. Nhấn số 327 kiểm thử = làm nghiêm túc, không phải đồ chơi.</a:t>
+              <a:t>Giải thích ERP bằng ngôn ngữ đời thường: toàn bộ công ty trên một hệ thống, một nguồn số thật. Nhấn 327 kiểm thử = làm nghiêm túc.</a:t>
             </a:r>
           </a:p>
         </p:txBody>
@@ -1028,7 +1028,7 @@
           <a:lstStyle/>
           <a:p>
             <a:r>
-              <a:t>Đi qua 6 bước theo hành trình 1 khách hàng thật. Chốt câu: không khách nào bị bỏ quên — đó là tiền của công ty và hoa hồng của các bạn.</a:t>
+              <a:t>Đi qua 6 bước theo hành trình 1 khách hàng thật. Chốt: không khách nào bị bỏ quên — đó là tiền của công ty và hoa hồng của các bạn.</a:t>
             </a:r>
           </a:p>
         </p:txBody>
@@ -1114,7 +1114,7 @@
           <a:lstStyle/>
           <a:p>
             <a:r>
-              <a:t>Slide quan trọng nhất với đội sales — nói chậm. Báo giá 30 giây NGAY TẠI NHÀ KHÁCH là vũ khí chốt deal. Hoa hồng minh bạch: ký xong thấy tiền của mình ngay trên app.</a:t>
+              <a:t>Slide quan trọng nhất với sales — nói chậm. Báo giá 30 giây NGAY TẠI NHÀ KHÁCH. Hoa hồng minh bạch: ký xong thấy tiền của mình ngay trên app.</a:t>
             </a:r>
           </a:p>
         </p:txBody>
@@ -1200,7 +1200,7 @@
           <a:lstStyle/>
           <a:p>
             <a:r>
-              <a:t>Dành cho anh em công trường: mọi thứ 1 chạm trên điện thoại, mất mạng vẫn chấm công được. Có chế độ màn hình ngoài trời — anh em đứng nắng vẫn đọc rõ.</a:t>
+              <a:t>Anh em công trường: mọi thứ 1 chạm, mất mạng vẫn chấm công. Chế độ màn hình ngoài trời — đứng nắng vẫn đọc rõ.</a:t>
             </a:r>
           </a:p>
         </p:txBody>
@@ -1286,7 +1286,7 @@
           <a:lstStyle/>
           <a:p>
             <a:r>
-              <a:t>Kế toán &amp; HR: nhập một lần, số tự chảy. Lương + thuế TNCN tự tính, phiếu lương gửi riêng từng người qua Telegram — công bằng, kín đáo.</a:t>
+              <a:t>Kế toán &amp; HR: nhập một lần, số tự chảy. Lương + thuế TNCN tự tính, phiếu lương gửi riêng từng người qua Telegram.</a:t>
             </a:r>
           </a:p>
         </p:txBody>
@@ -1458,7 +1458,7 @@
           <a:lstStyle/>
           <a:p>
             <a:r>
-              <a:t>Điểm nhấn công nghệ: AI + bot làm việc cả đêm. Khung nói: việc lặp lại để máy lo, con người dành cho khách hàng.</a:t>
+              <a:t>AI + bot làm việc cả đêm. Khung nói: việc lặp lại để máy lo, con người dành cho khách hàng.</a:t>
             </a:r>
           </a:p>
         </p:txBody>
@@ -1874,177 +1874,9 @@
           <a:ln/>
         </p:spPr>
       </p:sp>
-      <p:sp>
-        <p:nvSpPr>
-          <p:cNvPr id="4" name="Text 2"/>
-          <p:cNvSpPr/>
-          <p:nvPr/>
-        </p:nvSpPr>
-        <p:spPr>
-          <a:xfrm>
-            <a:off x="0" y="932688"/>
-            <a:ext cx="12188952" cy="365760"/>
-          </a:xfrm>
-          <a:prstGeom prst="rect">
-            <a:avLst/>
-          </a:prstGeom>
-          <a:noFill/>
-          <a:ln/>
-        </p:spPr>
-        <p:txBody>
-          <a:bodyPr wrap="square" lIns="0" tIns="0" rIns="0" bIns="0" rtlCol="0" anchor="ctr"/>
-          <a:lstStyle/>
-          <a:p>
-            <a:pPr algn="ctr" indent="0" marL="0">
-              <a:buNone/>
-            </a:pPr>
-            <a:r>
-              <a:rPr lang="en-US" sz="1500" b="1" spc="500" kern="0" dirty="0">
-                <a:solidFill>
-                  <a:srgbClr val="AAB8CB"/>
-                </a:solidFill>
-              </a:rPr>
-              <a:t>KỶ NIỆM THÀNH LẬP CÔNG TY</a:t>
-            </a:r>
-            <a:endParaRPr lang="en-US" sz="1500" dirty="0"/>
-          </a:p>
-        </p:txBody>
-      </p:sp>
-      <p:sp>
-        <p:nvSpPr>
-          <p:cNvPr id="5" name="Text 3"/>
-          <p:cNvSpPr/>
-          <p:nvPr/>
-        </p:nvSpPr>
-        <p:spPr>
-          <a:xfrm>
-            <a:off x="0" y="1371600"/>
-            <a:ext cx="12188952" cy="1371600"/>
-          </a:xfrm>
-          <a:prstGeom prst="rect">
-            <a:avLst/>
-          </a:prstGeom>
-          <a:noFill/>
-          <a:ln/>
-        </p:spPr>
-        <p:txBody>
-          <a:bodyPr wrap="square" lIns="0" tIns="0" rIns="0" bIns="0" rtlCol="0" anchor="ctr"/>
-          <a:lstStyle/>
-          <a:p>
-            <a:pPr algn="ctr" indent="0" marL="0">
-              <a:buNone/>
-            </a:pPr>
-            <a:r>
-              <a:rPr lang="en-US" sz="7200" b="1" dirty="0">
-                <a:solidFill>
-                  <a:srgbClr val="C9A96E"/>
-                </a:solidFill>
-                <a:latin typeface="Cambria" pitchFamily="34" charset="0"/>
-                <a:ea typeface="Cambria" pitchFamily="34" charset="-122"/>
-                <a:cs typeface="Cambria" pitchFamily="34" charset="-120"/>
-              </a:rPr>
-              <a:t>10 NĂM </a:t>
-            </a:r>
-            <a:pPr algn="ctr" indent="0" marL="0">
-              <a:buNone/>
-            </a:pPr>
-            <a:r>
-              <a:rPr lang="en-US" sz="7200" b="1" dirty="0">
-                <a:solidFill>
-                  <a:srgbClr val="FFFFFF"/>
-                </a:solidFill>
-                <a:latin typeface="Cambria" pitchFamily="34" charset="0"/>
-                <a:ea typeface="Cambria" pitchFamily="34" charset="-122"/>
-                <a:cs typeface="Cambria" pitchFamily="34" charset="-120"/>
-              </a:rPr>
-              <a:t>JAMA HOME</a:t>
-            </a:r>
-            <a:endParaRPr lang="en-US" sz="7200" dirty="0"/>
-          </a:p>
-        </p:txBody>
-      </p:sp>
-      <p:sp>
-        <p:nvSpPr>
-          <p:cNvPr id="6" name="Text 4"/>
-          <p:cNvSpPr/>
-          <p:nvPr/>
-        </p:nvSpPr>
-        <p:spPr>
-          <a:xfrm>
-            <a:off x="0" y="2761488"/>
-            <a:ext cx="12188952" cy="457200"/>
-          </a:xfrm>
-          <a:prstGeom prst="rect">
-            <a:avLst/>
-          </a:prstGeom>
-          <a:noFill/>
-          <a:ln/>
-        </p:spPr>
-        <p:txBody>
-          <a:bodyPr wrap="square" lIns="0" tIns="0" rIns="0" bIns="0" rtlCol="0" anchor="ctr"/>
-          <a:lstStyle/>
-          <a:p>
-            <a:pPr algn="ctr" indent="0" marL="0">
-              <a:buNone/>
-            </a:pPr>
-            <a:r>
-              <a:rPr lang="en-US" sz="2000" i="1" dirty="0">
-                <a:solidFill>
-                  <a:srgbClr val="C9A96E"/>
-                </a:solidFill>
-              </a:rPr>
-              <a:t>Thiết kế cho cuộc sống mới</a:t>
-            </a:r>
-            <a:endParaRPr lang="en-US" sz="2000" dirty="0"/>
-          </a:p>
-        </p:txBody>
-      </p:sp>
-      <p:sp>
-        <p:nvSpPr>
-          <p:cNvPr id="7" name="Shape 5"/>
-          <p:cNvSpPr/>
-          <p:nvPr/>
-        </p:nvSpPr>
-        <p:spPr>
-          <a:xfrm>
-            <a:off x="4082796" y="3529584"/>
-            <a:ext cx="1554480" cy="0"/>
-          </a:xfrm>
-          <a:prstGeom prst="line">
-            <a:avLst/>
-          </a:prstGeom>
-          <a:noFill/>
-          <a:ln w="12700">
-            <a:solidFill>
-              <a:srgbClr val="B8935A"/>
-            </a:solidFill>
-            <a:prstDash val="solid"/>
-          </a:ln>
-        </p:spPr>
-      </p:sp>
-      <p:sp>
-        <p:nvSpPr>
-          <p:cNvPr id="8" name="Shape 6"/>
-          <p:cNvSpPr/>
-          <p:nvPr/>
-        </p:nvSpPr>
-        <p:spPr>
-          <a:xfrm>
-            <a:off x="5811012" y="3246120"/>
-            <a:ext cx="566928" cy="566928"/>
-          </a:xfrm>
-          <a:prstGeom prst="ellipse">
-            <a:avLst/>
-          </a:prstGeom>
-          <a:solidFill>
-            <a:srgbClr val="C9A96E"/>
-          </a:solidFill>
-          <a:ln/>
-        </p:spPr>
-      </p:sp>
       <p:pic>
         <p:nvPicPr>
-          <p:cNvPr id="9" name="Image 0" descr="preencoded.png">    </p:cNvPr>
+          <p:cNvPr id="4" name="Image 0" descr="preencoded.png">    </p:cNvPr>
           <p:cNvPicPr>
             <a:picLocks noChangeAspect="1"/>
           </p:cNvPicPr>
@@ -2058,8 +1890,8 @@
         </p:blipFill>
         <p:spPr>
           <a:xfrm>
-            <a:off x="5935736" y="3370844"/>
-            <a:ext cx="317480" cy="317480"/>
+            <a:off x="4841748" y="384048"/>
+            <a:ext cx="2505456" cy="685800"/>
           </a:xfrm>
           <a:prstGeom prst="rect">
             <a:avLst/>
@@ -2068,36 +1900,124 @@
       </p:pic>
       <p:sp>
         <p:nvSpPr>
-          <p:cNvPr id="10" name="Shape 7"/>
-          <p:cNvSpPr/>
-          <p:nvPr/>
-        </p:nvSpPr>
-        <p:spPr>
-          <a:xfrm>
-            <a:off x="6551676" y="3529584"/>
-            <a:ext cx="1554480" cy="0"/>
-          </a:xfrm>
-          <a:prstGeom prst="line">
-            <a:avLst/>
-          </a:prstGeom>
-          <a:noFill/>
-          <a:ln w="12700">
-            <a:solidFill>
-              <a:srgbClr val="B8935A"/>
-            </a:solidFill>
-            <a:prstDash val="solid"/>
-          </a:ln>
-        </p:spPr>
-      </p:sp>
-      <p:sp>
-        <p:nvSpPr>
-          <p:cNvPr id="11" name="Text 8"/>
-          <p:cNvSpPr/>
-          <p:nvPr/>
-        </p:nvSpPr>
-        <p:spPr>
-          <a:xfrm>
-            <a:off x="0" y="4041648"/>
+          <p:cNvPr id="5" name="Text 2"/>
+          <p:cNvSpPr/>
+          <p:nvPr/>
+        </p:nvSpPr>
+        <p:spPr>
+          <a:xfrm>
+            <a:off x="0" y="1207008"/>
+            <a:ext cx="12188952" cy="347472"/>
+          </a:xfrm>
+          <a:prstGeom prst="rect">
+            <a:avLst/>
+          </a:prstGeom>
+          <a:noFill/>
+          <a:ln/>
+        </p:spPr>
+        <p:txBody>
+          <a:bodyPr wrap="square" lIns="0" tIns="0" rIns="0" bIns="0" rtlCol="0" anchor="ctr"/>
+          <a:lstStyle/>
+          <a:p>
+            <a:pPr algn="ctr" indent="0" marL="0">
+              <a:buNone/>
+            </a:pPr>
+            <a:r>
+              <a:rPr lang="en-US" sz="1400" b="1" spc="500" kern="0" dirty="0">
+                <a:solidFill>
+                  <a:srgbClr val="AAB8CB"/>
+                </a:solidFill>
+              </a:rPr>
+              <a:t>KỶ NIỆM 10 NĂM THÀNH LẬP</a:t>
+            </a:r>
+            <a:endParaRPr lang="en-US" sz="1400" dirty="0"/>
+          </a:p>
+        </p:txBody>
+      </p:sp>
+      <p:sp>
+        <p:nvSpPr>
+          <p:cNvPr id="6" name="Text 3"/>
+          <p:cNvSpPr/>
+          <p:nvPr/>
+        </p:nvSpPr>
+        <p:spPr>
+          <a:xfrm>
+            <a:off x="0" y="1481328"/>
+            <a:ext cx="12188952" cy="1371600"/>
+          </a:xfrm>
+          <a:prstGeom prst="rect">
+            <a:avLst/>
+          </a:prstGeom>
+          <a:noFill/>
+          <a:ln/>
+        </p:spPr>
+        <p:txBody>
+          <a:bodyPr wrap="square" lIns="0" tIns="0" rIns="0" bIns="0" rtlCol="0" anchor="ctr"/>
+          <a:lstStyle/>
+          <a:p>
+            <a:pPr algn="ctr" indent="0" marL="0">
+              <a:buNone/>
+            </a:pPr>
+            <a:r>
+              <a:rPr lang="en-US" sz="8400" b="1" dirty="0">
+                <a:solidFill>
+                  <a:srgbClr val="C9A96E"/>
+                </a:solidFill>
+                <a:latin typeface="Cambria" pitchFamily="34" charset="0"/>
+                <a:ea typeface="Cambria" pitchFamily="34" charset="-122"/>
+                <a:cs typeface="Cambria" pitchFamily="34" charset="-120"/>
+              </a:rPr>
+              <a:t>10 NĂM</a:t>
+            </a:r>
+            <a:endParaRPr lang="en-US" sz="8400" dirty="0"/>
+          </a:p>
+        </p:txBody>
+      </p:sp>
+      <p:sp>
+        <p:nvSpPr>
+          <p:cNvPr id="7" name="Text 4"/>
+          <p:cNvSpPr/>
+          <p:nvPr/>
+        </p:nvSpPr>
+        <p:spPr>
+          <a:xfrm>
+            <a:off x="0" y="2871216"/>
+            <a:ext cx="12188952" cy="411480"/>
+          </a:xfrm>
+          <a:prstGeom prst="rect">
+            <a:avLst/>
+          </a:prstGeom>
+          <a:noFill/>
+          <a:ln/>
+        </p:spPr>
+        <p:txBody>
+          <a:bodyPr wrap="square" lIns="0" tIns="0" rIns="0" bIns="0" rtlCol="0" anchor="ctr"/>
+          <a:lstStyle/>
+          <a:p>
+            <a:pPr algn="ctr" indent="0" marL="0">
+              <a:buNone/>
+            </a:pPr>
+            <a:r>
+              <a:rPr lang="en-US" sz="1900" i="1" dirty="0">
+                <a:solidFill>
+                  <a:srgbClr val="C9A96E"/>
+                </a:solidFill>
+              </a:rPr>
+              <a:t>Thiết kế cho cuộc sống mới</a:t>
+            </a:r>
+            <a:endParaRPr lang="en-US" sz="1900" dirty="0"/>
+          </a:p>
+        </p:txBody>
+      </p:sp>
+      <p:sp>
+        <p:nvSpPr>
+          <p:cNvPr id="8" name="Text 5"/>
+          <p:cNvSpPr/>
+          <p:nvPr/>
+        </p:nvSpPr>
+        <p:spPr>
+          <a:xfrm>
+            <a:off x="0" y="3401568"/>
             <a:ext cx="12188952" cy="457200"/>
           </a:xfrm>
           <a:prstGeom prst="rect">
@@ -2114,27 +2034,27 @@
               <a:buNone/>
             </a:pPr>
             <a:r>
-              <a:rPr lang="en-US" sz="2400" b="1" spc="200" kern="0" dirty="0">
+              <a:rPr lang="en-US" sz="2500" b="1" spc="200" kern="0" dirty="0">
                 <a:solidFill>
                   <a:srgbClr val="FFFFFF"/>
                 </a:solidFill>
               </a:rPr>
               <a:t>RA MẮT HỆ THỐNG JAMA ERP</a:t>
             </a:r>
-            <a:endParaRPr lang="en-US" sz="2400" dirty="0"/>
-          </a:p>
-        </p:txBody>
-      </p:sp>
-      <p:sp>
-        <p:nvSpPr>
-          <p:cNvPr id="12" name="Text 9"/>
-          <p:cNvSpPr/>
-          <p:nvPr/>
-        </p:nvSpPr>
-        <p:spPr>
-          <a:xfrm>
-            <a:off x="0" y="4526280"/>
-            <a:ext cx="12188952" cy="365760"/>
+            <a:endParaRPr lang="en-US" sz="2500" dirty="0"/>
+          </a:p>
+        </p:txBody>
+      </p:sp>
+      <p:sp>
+        <p:nvSpPr>
+          <p:cNvPr id="9" name="Text 6"/>
+          <p:cNvSpPr/>
+          <p:nvPr/>
+        </p:nvSpPr>
+        <p:spPr>
+          <a:xfrm>
+            <a:off x="0" y="3895344"/>
+            <a:ext cx="12188952" cy="347472"/>
           </a:xfrm>
           <a:prstGeom prst="rect">
             <a:avLst/>
@@ -2150,27 +2070,99 @@
               <a:buNone/>
             </a:pPr>
             <a:r>
-              <a:rPr lang="en-US" sz="1500" dirty="0">
+              <a:rPr lang="en-US" sz="1300" dirty="0">
                 <a:solidFill>
                   <a:srgbClr val="AAB8CB"/>
                 </a:solidFill>
               </a:rPr>
-              <a:t>Hệ điều hành số của chúng ta cho thập kỷ bứt phá tiếp theo</a:t>
-            </a:r>
-            <a:endParaRPr lang="en-US" sz="1500" dirty="0"/>
-          </a:p>
-        </p:txBody>
-      </p:sp>
-      <p:sp>
-        <p:nvSpPr>
-          <p:cNvPr id="13" name="Text 10"/>
-          <p:cNvSpPr/>
-          <p:nvPr/>
-        </p:nvSpPr>
-        <p:spPr>
-          <a:xfrm>
-            <a:off x="0" y="6126480"/>
-            <a:ext cx="12188952" cy="320040"/>
+              <a:t>Hệ điều hành số của chúng ta cho thập kỷ bứt phá tiếp theo · Sự kiện nội bộ — BOD &amp; toàn thể thành viên</a:t>
+            </a:r>
+            <a:endParaRPr lang="en-US" sz="1300" dirty="0"/>
+          </a:p>
+        </p:txBody>
+      </p:sp>
+      <p:pic>
+        <p:nvPicPr>
+          <p:cNvPr id="10" name="Image 1" descr="preencoded.png">    </p:cNvPr>
+          <p:cNvPicPr>
+            <a:picLocks noChangeAspect="1"/>
+          </p:cNvPicPr>
+          <p:nvPr/>
+        </p:nvPicPr>
+        <p:blipFill>
+          <a:blip r:embed="rId2"/>
+          <a:stretch>
+            <a:fillRect/>
+          </a:stretch>
+        </p:blipFill>
+        <p:spPr>
+          <a:xfrm>
+            <a:off x="1970532" y="4498848"/>
+            <a:ext cx="2596896" cy="1737360"/>
+          </a:xfrm>
+          <a:prstGeom prst="rect">
+            <a:avLst/>
+          </a:prstGeom>
+        </p:spPr>
+      </p:pic>
+      <p:pic>
+        <p:nvPicPr>
+          <p:cNvPr id="11" name="Image 2" descr="preencoded.png">    </p:cNvPr>
+          <p:cNvPicPr>
+            <a:picLocks noChangeAspect="1"/>
+          </p:cNvPicPr>
+          <p:nvPr/>
+        </p:nvPicPr>
+        <p:blipFill>
+          <a:blip r:embed="rId3"/>
+          <a:stretch>
+            <a:fillRect/>
+          </a:stretch>
+        </p:blipFill>
+        <p:spPr>
+          <a:xfrm>
+            <a:off x="4796028" y="4498848"/>
+            <a:ext cx="2596896" cy="1737360"/>
+          </a:xfrm>
+          <a:prstGeom prst="rect">
+            <a:avLst/>
+          </a:prstGeom>
+        </p:spPr>
+      </p:pic>
+      <p:pic>
+        <p:nvPicPr>
+          <p:cNvPr id="12" name="Image 3" descr="preencoded.png">    </p:cNvPr>
+          <p:cNvPicPr>
+            <a:picLocks noChangeAspect="1"/>
+          </p:cNvPicPr>
+          <p:nvPr/>
+        </p:nvPicPr>
+        <p:blipFill>
+          <a:blip r:embed="rId4"/>
+          <a:stretch>
+            <a:fillRect/>
+          </a:stretch>
+        </p:blipFill>
+        <p:spPr>
+          <a:xfrm>
+            <a:off x="7621524" y="4498848"/>
+            <a:ext cx="2596896" cy="1737360"/>
+          </a:xfrm>
+          <a:prstGeom prst="rect">
+            <a:avLst/>
+          </a:prstGeom>
+        </p:spPr>
+      </p:pic>
+      <p:sp>
+        <p:nvSpPr>
+          <p:cNvPr id="13" name="Text 7"/>
+          <p:cNvSpPr/>
+          <p:nvPr/>
+        </p:nvSpPr>
+        <p:spPr>
+          <a:xfrm>
+            <a:off x="0" y="6327648"/>
+            <a:ext cx="12188952" cy="292608"/>
           </a:xfrm>
           <a:prstGeom prst="rect">
             <a:avLst/>
@@ -2186,14 +2178,14 @@
               <a:buNone/>
             </a:pPr>
             <a:r>
-              <a:rPr lang="en-US" sz="1150" dirty="0">
+              <a:rPr lang="en-US" sz="1050" i="1" dirty="0">
                 <a:solidFill>
                   <a:srgbClr val="AAB8CB"/>
                 </a:solidFill>
               </a:rPr>
-              <a:t>Sự kiện nội bộ · BOD &amp; toàn thể thành viên JAMA HOME</a:t>
-            </a:r>
-            <a:endParaRPr lang="en-US" sz="1150" dirty="0"/>
+              <a:t>Công trình thật của chúng ta — Q7 · Bình Chánh · Gò Vấp</a:t>
+            </a:r>
+            <a:endParaRPr lang="en-US" sz="1050" dirty="0"/>
           </a:p>
         </p:txBody>
       </p:sp>
@@ -3832,7 +3824,7 @@
         <p:spPr>
           <a:xfrm>
             <a:off x="1325880" y="1746504"/>
-            <a:ext cx="9875520" cy="365760"/>
+            <a:ext cx="5760720" cy="365760"/>
           </a:xfrm>
           <a:prstGeom prst="rect">
             <a:avLst/>
@@ -3868,7 +3860,7 @@
         <p:spPr>
           <a:xfrm>
             <a:off x="1325880" y="2084832"/>
-            <a:ext cx="9875520" cy="457200"/>
+            <a:ext cx="5760720" cy="457200"/>
           </a:xfrm>
           <a:prstGeom prst="rect">
             <a:avLst/>
@@ -3960,7 +3952,7 @@
         <p:spPr>
           <a:xfrm>
             <a:off x="1325880" y="2734056"/>
-            <a:ext cx="9875520" cy="365760"/>
+            <a:ext cx="5760720" cy="365760"/>
           </a:xfrm>
           <a:prstGeom prst="rect">
             <a:avLst/>
@@ -3996,7 +3988,7 @@
         <p:spPr>
           <a:xfrm>
             <a:off x="1325880" y="3072384"/>
-            <a:ext cx="9875520" cy="457200"/>
+            <a:ext cx="5760720" cy="457200"/>
           </a:xfrm>
           <a:prstGeom prst="rect">
             <a:avLst/>
@@ -4088,7 +4080,7 @@
         <p:spPr>
           <a:xfrm>
             <a:off x="1325880" y="3721608"/>
-            <a:ext cx="9875520" cy="365760"/>
+            <a:ext cx="5760720" cy="365760"/>
           </a:xfrm>
           <a:prstGeom prst="rect">
             <a:avLst/>
@@ -4124,7 +4116,7 @@
         <p:spPr>
           <a:xfrm>
             <a:off x="1325880" y="4059936"/>
-            <a:ext cx="9875520" cy="457200"/>
+            <a:ext cx="5760720" cy="457200"/>
           </a:xfrm>
           <a:prstGeom prst="rect">
             <a:avLst/>
@@ -4151,9 +4143,69 @@
           </a:p>
         </p:txBody>
       </p:sp>
-      <p:sp>
-        <p:nvSpPr>
-          <p:cNvPr id="18" name="Shape 16"/>
+      <p:pic>
+        <p:nvPicPr>
+          <p:cNvPr id="18" name="Image 0" descr="preencoded.png">    </p:cNvPr>
+          <p:cNvPicPr>
+            <a:picLocks noChangeAspect="1"/>
+          </p:cNvPicPr>
+          <p:nvPr/>
+        </p:nvPicPr>
+        <p:blipFill>
+          <a:blip r:embed="rId1"/>
+          <a:stretch>
+            <a:fillRect/>
+          </a:stretch>
+        </p:blipFill>
+        <p:spPr>
+          <a:xfrm>
+            <a:off x="7452360" y="1755648"/>
+            <a:ext cx="4169664" cy="2779776"/>
+          </a:xfrm>
+          <a:prstGeom prst="rect">
+            <a:avLst/>
+          </a:prstGeom>
+        </p:spPr>
+      </p:pic>
+      <p:sp>
+        <p:nvSpPr>
+          <p:cNvPr id="19" name="Text 16"/>
+          <p:cNvSpPr/>
+          <p:nvPr/>
+        </p:nvSpPr>
+        <p:spPr>
+          <a:xfrm>
+            <a:off x="7452360" y="4572000"/>
+            <a:ext cx="4169664" cy="274320"/>
+          </a:xfrm>
+          <a:prstGeom prst="rect">
+            <a:avLst/>
+          </a:prstGeom>
+          <a:noFill/>
+          <a:ln/>
+        </p:spPr>
+        <p:txBody>
+          <a:bodyPr wrap="square" lIns="0" tIns="0" rIns="0" bIns="0" rtlCol="0" anchor="ctr"/>
+          <a:lstStyle/>
+          <a:p>
+            <a:pPr algn="ctr" indent="0" marL="0">
+              <a:buNone/>
+            </a:pPr>
+            <a:r>
+              <a:rPr lang="en-US" sz="1000" i="1" dirty="0">
+                <a:solidFill>
+                  <a:srgbClr val="AAB8CB"/>
+                </a:solidFill>
+              </a:rPr>
+              <a:t>Đội ngũ JAMA HOME — teambuilding</a:t>
+            </a:r>
+            <a:endParaRPr lang="en-US" sz="1000" dirty="0"/>
+          </a:p>
+        </p:txBody>
+      </p:sp>
+      <p:sp>
+        <p:nvSpPr>
+          <p:cNvPr id="20" name="Shape 17"/>
           <p:cNvSpPr/>
           <p:nvPr/>
         </p:nvSpPr>
@@ -4176,7 +4228,7 @@
       </p:sp>
       <p:sp>
         <p:nvSpPr>
-          <p:cNvPr id="19" name="Text 17"/>
+          <p:cNvPr id="21" name="Text 18"/>
           <p:cNvSpPr/>
           <p:nvPr/>
         </p:nvSpPr>
@@ -4243,7 +4295,7 @@
       </p:sp>
       <p:sp>
         <p:nvSpPr>
-          <p:cNvPr id="20" name="Text 18"/>
+          <p:cNvPr id="22" name="Text 19"/>
           <p:cNvSpPr/>
           <p:nvPr/>
         </p:nvSpPr>
@@ -4541,7 +4593,7 @@
                   <a:srgbClr val="AAB8CB"/>
                 </a:solidFill>
               </a:rPr>
-              <a:t>Từ đội ngũ nhỏ thành công ty 100+ thành viên, 5 phòng ban — được khách hàng tin giao tổ ấm của họ.</a:t>
+              <a:t>Từ đội ngũ nhỏ thành công ty 100+ thành viên — dẫn đầu mảng cải tạo nhà trọn gói tại TP.HCM &amp; miền Tây.</a:t>
             </a:r>
             <a:endParaRPr lang="en-US" sz="1250" dirty="0"/>
           </a:p>
@@ -5289,7 +5341,7 @@
                 <a:ea typeface="Cambria" pitchFamily="34" charset="-122"/>
                 <a:cs typeface="Cambria" pitchFamily="34" charset="-120"/>
               </a:rPr>
-              <a:t>1</a:t>
+              <a:t>100+</a:t>
             </a:r>
             <a:endParaRPr lang="en-US" sz="4000" dirty="0"/>
           </a:p>
@@ -5325,7 +5377,7 @@
                   <a:srgbClr val="FFFFFF"/>
                 </a:solidFill>
               </a:rPr>
-              <a:t>đội ngũ</a:t>
+              <a:t>công trình cải tạo</a:t>
             </a:r>
             <a:endParaRPr lang="en-US" sz="1400" dirty="0"/>
           </a:p>
@@ -5361,7 +5413,7 @@
                   <a:srgbClr val="AAB8CB"/>
                 </a:solidFill>
               </a:rPr>
-              <a:t>một mục tiêu chung</a:t>
+              <a:t>riêng năm 2025 — dẫn đầu TP</a:t>
             </a:r>
             <a:endParaRPr lang="en-US" sz="1050" dirty="0"/>
           </a:p>

</xml_diff>